<commit_message>
study(0805) : React_State & Event
</commit_message>
<xml_diff>
--- a/material/[SeSAC_YDP_6] 24_React_Props_State.pptx
+++ b/material/[SeSAC_YDP_6] 24_React_Props_State.pptx
@@ -220,7 +220,7 @@
           <a:p>
             <a:fld id="{2EF3F159-7250-4DD4-91C2-13B35D56E1AF}" type="datetimeFigureOut">
               <a:rPr lang="ko-KR" altLang="en-US" smtClean="0"/>
-              <a:t>2024-08-04</a:t>
+              <a:t>2024-08-05</a:t>
             </a:fld>
             <a:endParaRPr lang="ko-KR" altLang="en-US"/>
           </a:p>
@@ -615,220 +615,7 @@
           <a:bodyPr/>
           <a:lstStyle/>
           <a:p>
-            <a:r>
-              <a:rPr lang="en-US" altLang="ko-KR" dirty="0"/>
-              <a:t>ex. </a:t>
-            </a:r>
-            <a:r>
-              <a:rPr lang="ko-KR" altLang="en-US" dirty="0" err="1"/>
-              <a:t>다크</a:t>
-            </a:r>
-            <a:r>
-              <a:rPr lang="en-US" altLang="ko-KR" dirty="0"/>
-              <a:t>/</a:t>
-            </a:r>
-            <a:r>
-              <a:rPr lang="ko-KR" altLang="en-US" dirty="0"/>
-              <a:t>라이트 모드</a:t>
-            </a:r>
-            <a:endParaRPr lang="en-US" altLang="ko-KR" dirty="0"/>
-          </a:p>
-          <a:p>
-            <a:pPr marL="171450" indent="-171450">
-              <a:buFontTx/>
-              <a:buChar char="-"/>
-            </a:pPr>
-            <a:endParaRPr lang="en-US" altLang="ko-KR" baseline="0" dirty="0" smtClean="0"/>
-          </a:p>
-          <a:p>
-            <a:pPr marL="171450" indent="-171450">
-              <a:buFontTx/>
-              <a:buChar char="-"/>
-            </a:pPr>
-            <a:endParaRPr lang="en-US" altLang="ko-KR" dirty="0" smtClean="0"/>
-          </a:p>
-          <a:p>
-            <a:pPr marL="0" indent="0">
-              <a:buFontTx/>
-              <a:buNone/>
-            </a:pPr>
-            <a:r>
-              <a:rPr lang="en-US" altLang="ko-KR" dirty="0" smtClean="0"/>
-              <a:t>-Why?</a:t>
-            </a:r>
-            <a:r>
-              <a:rPr lang="en-US" altLang="ko-KR" baseline="0" dirty="0" smtClean="0"/>
-              <a:t> State</a:t>
-            </a:r>
-            <a:r>
-              <a:rPr lang="ko-KR" altLang="en-US" baseline="0" dirty="0" smtClean="0"/>
-              <a:t>를 사용해야 하는 이유</a:t>
-            </a:r>
-            <a:r>
-              <a:rPr lang="en-US" altLang="ko-KR" baseline="0" dirty="0" smtClean="0"/>
-              <a:t>?</a:t>
-            </a:r>
-            <a:endParaRPr lang="en-US" altLang="ko-KR" dirty="0" smtClean="0"/>
-          </a:p>
-          <a:p>
-            <a:endParaRPr lang="en-US" altLang="ko-KR" dirty="0"/>
-          </a:p>
-          <a:p>
-            <a:r>
-              <a:rPr lang="en-US" altLang="ko-KR" dirty="0" smtClean="0"/>
-              <a:t>State</a:t>
-            </a:r>
-            <a:r>
-              <a:rPr lang="ko-KR" altLang="en-US" dirty="0" smtClean="0"/>
-              <a:t>는 컴포넌트가 유지하는 데이터</a:t>
-            </a:r>
-            <a:r>
-              <a:rPr lang="en-US" altLang="ko-KR" dirty="0" smtClean="0"/>
-              <a:t>, </a:t>
-            </a:r>
-            <a:r>
-              <a:rPr lang="ko-KR" altLang="en-US" dirty="0" smtClean="0"/>
-              <a:t>변경될 때마다 컴포넌트가 다시 </a:t>
-            </a:r>
-            <a:r>
-              <a:rPr lang="ko-KR" altLang="en-US" dirty="0" err="1" smtClean="0"/>
-              <a:t>재랜더링되어</a:t>
-            </a:r>
-            <a:r>
-              <a:rPr lang="ko-KR" altLang="en-US" dirty="0" smtClean="0"/>
-              <a:t> 사용자에게 최신 상태를 보여줌</a:t>
-            </a:r>
-            <a:r>
-              <a:rPr lang="en-US" altLang="ko-KR" dirty="0" smtClean="0"/>
-              <a:t>.</a:t>
-            </a:r>
-            <a:endParaRPr lang="en-US" altLang="ko-KR" dirty="0"/>
-          </a:p>
-          <a:p>
-            <a:pPr marL="171450" indent="-171450">
-              <a:buFontTx/>
-              <a:buChar char="-"/>
-            </a:pPr>
-            <a:r>
-              <a:rPr lang="ko-KR" altLang="en-US" dirty="0" smtClean="0"/>
-              <a:t>이 </a:t>
-            </a:r>
-            <a:r>
-              <a:rPr lang="ko-KR" altLang="en-US" dirty="0"/>
-              <a:t>점이 </a:t>
-            </a:r>
-            <a:r>
-              <a:rPr lang="ko-KR" altLang="en-US" dirty="0" err="1"/>
-              <a:t>변수랑</a:t>
-            </a:r>
-            <a:r>
-              <a:rPr lang="ko-KR" altLang="en-US" dirty="0"/>
-              <a:t> 다른 것이다</a:t>
-            </a:r>
-            <a:r>
-              <a:rPr lang="en-US" altLang="ko-KR" dirty="0" smtClean="0"/>
-              <a:t>.</a:t>
-            </a:r>
-          </a:p>
-          <a:p>
-            <a:pPr marL="171450" indent="-171450">
-              <a:buFontTx/>
-              <a:buChar char="-"/>
-            </a:pPr>
-            <a:r>
-              <a:rPr lang="en-US" altLang="ko-KR" dirty="0" smtClean="0"/>
-              <a:t>Virtual DOM –</a:t>
-            </a:r>
-            <a:r>
-              <a:rPr lang="en-US" altLang="ko-KR" baseline="0" dirty="0" smtClean="0"/>
-              <a:t> </a:t>
-            </a:r>
-            <a:r>
-              <a:rPr lang="ko-KR" altLang="en-US" baseline="0" dirty="0" smtClean="0"/>
-              <a:t>변한 부분만 바꿔서 적용</a:t>
-            </a:r>
-            <a:r>
-              <a:rPr lang="en-US" altLang="ko-KR" baseline="0" dirty="0" smtClean="0"/>
-              <a:t>.</a:t>
-            </a:r>
-          </a:p>
-          <a:p>
-            <a:pPr marL="171450" indent="-171450">
-              <a:buFontTx/>
-              <a:buChar char="-"/>
-            </a:pPr>
-            <a:endParaRPr lang="en-US" altLang="ko-KR" baseline="0" dirty="0" smtClean="0"/>
-          </a:p>
-          <a:p>
-            <a:pPr marL="0" indent="0">
-              <a:buFontTx/>
-              <a:buNone/>
-            </a:pPr>
-            <a:r>
-              <a:rPr lang="en-US" altLang="ko-KR" baseline="0" dirty="0" smtClean="0"/>
-              <a:t>* When? </a:t>
-            </a:r>
-            <a:r>
-              <a:rPr lang="ko-KR" altLang="en-US" baseline="0" dirty="0" smtClean="0"/>
-              <a:t>언제 사용해야 할까</a:t>
-            </a:r>
-            <a:r>
-              <a:rPr lang="en-US" altLang="ko-KR" baseline="0" dirty="0" smtClean="0"/>
-              <a:t>?</a:t>
-            </a:r>
-          </a:p>
-          <a:p>
-            <a:pPr marL="171450" indent="-171450">
-              <a:buFontTx/>
-              <a:buChar char="-"/>
-            </a:pPr>
-            <a:r>
-              <a:rPr lang="ko-KR" altLang="en-US" baseline="0" dirty="0" err="1" smtClean="0"/>
-              <a:t>변경시</a:t>
-            </a:r>
-            <a:r>
-              <a:rPr lang="ko-KR" altLang="en-US" baseline="0" dirty="0" smtClean="0"/>
-              <a:t> 자동으로 </a:t>
-            </a:r>
-            <a:r>
-              <a:rPr lang="en-US" altLang="ko-KR" baseline="0" dirty="0" smtClean="0"/>
-              <a:t>HTML</a:t>
-            </a:r>
-            <a:r>
-              <a:rPr lang="ko-KR" altLang="en-US" baseline="0" dirty="0" smtClean="0"/>
-              <a:t>에 반영되게 만들고 싶은 기능에 </a:t>
-            </a:r>
-            <a:r>
-              <a:rPr lang="en-US" altLang="ko-KR" baseline="0" dirty="0" smtClean="0"/>
-              <a:t>state </a:t>
-            </a:r>
-            <a:r>
-              <a:rPr lang="ko-KR" altLang="en-US" baseline="0" dirty="0" smtClean="0"/>
-              <a:t>사용</a:t>
-            </a:r>
-            <a:r>
-              <a:rPr lang="en-US" altLang="ko-KR" baseline="0" dirty="0" smtClean="0"/>
-              <a:t>.</a:t>
-            </a:r>
-          </a:p>
-          <a:p>
-            <a:pPr marL="171450" indent="-171450">
-              <a:buFontTx/>
-              <a:buChar char="-"/>
-            </a:pPr>
-            <a:r>
-              <a:rPr lang="ko-KR" altLang="en-US" baseline="0" dirty="0" smtClean="0"/>
-              <a:t>자주 변경될 것 같은 </a:t>
-            </a:r>
-            <a:r>
-              <a:rPr lang="en-US" altLang="ko-KR" baseline="0" dirty="0" smtClean="0"/>
-              <a:t>html </a:t>
-            </a:r>
-            <a:r>
-              <a:rPr lang="ko-KR" altLang="en-US" baseline="0" dirty="0" smtClean="0"/>
-              <a:t>요소나 내용</a:t>
-            </a:r>
-            <a:endParaRPr lang="en-US" altLang="ko-KR" baseline="0" dirty="0" smtClean="0"/>
+            <a:endParaRPr lang="ko-KR" altLang="en-US" dirty="0"/>
           </a:p>
         </p:txBody>
       </p:sp>
@@ -849,7 +636,7 @@
           <a:p>
             <a:fld id="{C09E5BFC-1559-42F1-8940-AB342D56BF02}" type="slidenum">
               <a:rPr lang="ko-KR" altLang="en-US" smtClean="0"/>
-              <a:t>13</a:t>
+              <a:t>12</a:t>
             </a:fld>
             <a:endParaRPr lang="ko-KR" altLang="en-US"/>
           </a:p>
@@ -858,7 +645,7 @@
     </p:spTree>
     <p:extLst>
       <p:ext uri="{BB962C8B-B14F-4D97-AF65-F5344CB8AC3E}">
-        <p14:creationId xmlns:p14="http://schemas.microsoft.com/office/powerpoint/2010/main" val="695242521"/>
+        <p14:creationId xmlns:p14="http://schemas.microsoft.com/office/powerpoint/2010/main" val="3949042368"/>
       </p:ext>
     </p:extLst>
   </p:cSld>
@@ -912,43 +699,92 @@
           <a:bodyPr/>
           <a:lstStyle/>
           <a:p>
+            <a:r>
+              <a:rPr lang="en-US" altLang="ko-KR" dirty="0"/>
+              <a:t>ex. </a:t>
+            </a:r>
+            <a:r>
+              <a:rPr lang="ko-KR" altLang="en-US" dirty="0" err="1"/>
+              <a:t>다크</a:t>
+            </a:r>
+            <a:r>
+              <a:rPr lang="en-US" altLang="ko-KR" dirty="0"/>
+              <a:t>/</a:t>
+            </a:r>
+            <a:r>
+              <a:rPr lang="ko-KR" altLang="en-US" dirty="0"/>
+              <a:t>라이트 모드</a:t>
+            </a:r>
+            <a:endParaRPr lang="en-US" altLang="ko-KR" dirty="0"/>
+          </a:p>
+          <a:p>
             <a:pPr marL="171450" indent="-171450">
               <a:buFontTx/>
               <a:buChar char="-"/>
             </a:pPr>
-            <a:r>
-              <a:rPr lang="en-US" altLang="ko-KR" dirty="0" smtClean="0"/>
-              <a:t>props</a:t>
-            </a:r>
-            <a:r>
-              <a:rPr lang="ko-KR" altLang="en-US" dirty="0" smtClean="0"/>
-              <a:t>는 자식입장에서는 수정이 불가능</a:t>
-            </a:r>
-            <a:r>
-              <a:rPr lang="en-US" altLang="ko-KR" dirty="0" smtClean="0"/>
-              <a:t>! </a:t>
-            </a:r>
-            <a:r>
-              <a:rPr lang="ko-KR" altLang="en-US" dirty="0" smtClean="0"/>
-              <a:t>읽기만 가능</a:t>
-            </a:r>
-            <a:r>
-              <a:rPr lang="en-US" altLang="ko-KR" dirty="0" smtClean="0"/>
-              <a:t>!</a:t>
-            </a:r>
+            <a:endParaRPr lang="en-US" altLang="ko-KR" baseline="0" dirty="0"/>
           </a:p>
           <a:p>
             <a:pPr marL="171450" indent="-171450">
               <a:buFontTx/>
               <a:buChar char="-"/>
             </a:pPr>
-            <a:r>
-              <a:rPr lang="ko-KR" altLang="en-US" dirty="0" smtClean="0"/>
-              <a:t>변경하려면 최초 유포자 측에서 수정해야함</a:t>
-            </a:r>
-            <a:r>
-              <a:rPr lang="en-US" altLang="ko-KR" dirty="0" smtClean="0"/>
-              <a:t>!</a:t>
+            <a:endParaRPr lang="en-US" altLang="ko-KR" dirty="0"/>
+          </a:p>
+          <a:p>
+            <a:pPr marL="0" indent="0">
+              <a:buFontTx/>
+              <a:buNone/>
+            </a:pPr>
+            <a:r>
+              <a:rPr lang="en-US" altLang="ko-KR" dirty="0"/>
+              <a:t>-Why?</a:t>
+            </a:r>
+            <a:r>
+              <a:rPr lang="en-US" altLang="ko-KR" baseline="0" dirty="0"/>
+              <a:t> State</a:t>
+            </a:r>
+            <a:r>
+              <a:rPr lang="ko-KR" altLang="en-US" baseline="0" dirty="0"/>
+              <a:t>를 사용해야 하는 이유</a:t>
+            </a:r>
+            <a:r>
+              <a:rPr lang="en-US" altLang="ko-KR" baseline="0" dirty="0"/>
+              <a:t>?</a:t>
+            </a:r>
+            <a:endParaRPr lang="en-US" altLang="ko-KR" dirty="0"/>
+          </a:p>
+          <a:p>
+            <a:endParaRPr lang="en-US" altLang="ko-KR" dirty="0"/>
+          </a:p>
+          <a:p>
+            <a:r>
+              <a:rPr lang="en-US" altLang="ko-KR" dirty="0"/>
+              <a:t>State</a:t>
+            </a:r>
+            <a:r>
+              <a:rPr lang="ko-KR" altLang="en-US" dirty="0"/>
+              <a:t>는 컴포넌트가 유지하는 데이터</a:t>
+            </a:r>
+            <a:r>
+              <a:rPr lang="en-US" altLang="ko-KR" dirty="0"/>
+              <a:t>, </a:t>
+            </a:r>
+            <a:r>
+              <a:rPr lang="ko-KR" altLang="en-US" dirty="0"/>
+              <a:t>변경될 때마다 컴포넌트가 다시 </a:t>
+            </a:r>
+            <a:r>
+              <a:rPr lang="ko-KR" altLang="en-US" dirty="0" err="1"/>
+              <a:t>재랜더링되어</a:t>
+            </a:r>
+            <a:r>
+              <a:rPr lang="ko-KR" altLang="en-US" dirty="0"/>
+              <a:t> 사용자에게 최신 상태를 보여줌</a:t>
+            </a:r>
+            <a:r>
+              <a:rPr lang="en-US" altLang="ko-KR" dirty="0"/>
+              <a:t>.</a:t>
             </a:r>
           </a:p>
           <a:p>
@@ -956,7 +792,51 @@
               <a:buFontTx/>
               <a:buChar char="-"/>
             </a:pPr>
-            <a:endParaRPr lang="en-US" altLang="ko-KR" dirty="0" smtClean="0"/>
+            <a:r>
+              <a:rPr lang="ko-KR" altLang="en-US" dirty="0"/>
+              <a:t>이 점이 </a:t>
+            </a:r>
+            <a:r>
+              <a:rPr lang="ko-KR" altLang="en-US" dirty="0" err="1"/>
+              <a:t>변수랑</a:t>
+            </a:r>
+            <a:r>
+              <a:rPr lang="ko-KR" altLang="en-US" dirty="0"/>
+              <a:t> 다른 것이다</a:t>
+            </a:r>
+            <a:r>
+              <a:rPr lang="en-US" altLang="ko-KR" dirty="0"/>
+              <a:t>.</a:t>
+            </a:r>
+          </a:p>
+          <a:p>
+            <a:pPr marL="171450" indent="-171450">
+              <a:buFontTx/>
+              <a:buChar char="-"/>
+            </a:pPr>
+            <a:r>
+              <a:rPr lang="en-US" altLang="ko-KR" dirty="0"/>
+              <a:t>Virtual DOM –</a:t>
+            </a:r>
+            <a:r>
+              <a:rPr lang="en-US" altLang="ko-KR" baseline="0" dirty="0"/>
+              <a:t> </a:t>
+            </a:r>
+            <a:r>
+              <a:rPr lang="ko-KR" altLang="en-US" baseline="0" dirty="0"/>
+              <a:t>변한 부분만 바꿔서 적용</a:t>
+            </a:r>
+            <a:r>
+              <a:rPr lang="en-US" altLang="ko-KR" baseline="0" dirty="0"/>
+              <a:t>.</a:t>
+            </a:r>
+          </a:p>
+          <a:p>
+            <a:pPr marL="171450" indent="-171450">
+              <a:buFontTx/>
+              <a:buChar char="-"/>
+            </a:pPr>
+            <a:endParaRPr lang="en-US" altLang="ko-KR" baseline="0" dirty="0"/>
           </a:p>
           <a:p>
             <a:pPr marL="0" indent="0">
@@ -964,14 +844,17 @@
               <a:buNone/>
             </a:pPr>
             <a:r>
-              <a:rPr lang="en-US" altLang="ko-KR" dirty="0" smtClean="0"/>
-              <a:t>*</a:t>
-            </a:r>
-            <a:r>
-              <a:rPr lang="en-US" altLang="ko-KR" baseline="0" dirty="0" smtClean="0"/>
-              <a:t> state</a:t>
-            </a:r>
-            <a:endParaRPr lang="en-US" altLang="ko-KR" dirty="0" smtClean="0"/>
+              <a:rPr lang="en-US" altLang="ko-KR" baseline="0" dirty="0"/>
+              <a:t>* When? </a:t>
+            </a:r>
+            <a:r>
+              <a:rPr lang="ko-KR" altLang="en-US" baseline="0" dirty="0"/>
+              <a:t>언제 사용해야 할까</a:t>
+            </a:r>
+            <a:r>
+              <a:rPr lang="en-US" altLang="ko-KR" baseline="0" dirty="0"/>
+              <a:t>?</a:t>
+            </a:r>
           </a:p>
           <a:p>
             <a:pPr marL="171450" indent="-171450">
@@ -979,17 +862,52 @@
               <a:buChar char="-"/>
             </a:pPr>
             <a:r>
-              <a:rPr lang="ko-KR" altLang="en-US" dirty="0" smtClean="0"/>
-              <a:t>변수같은 존재</a:t>
-            </a:r>
-            <a:endParaRPr lang="en-US" altLang="ko-KR" dirty="0" smtClean="0"/>
+              <a:rPr lang="ko-KR" altLang="en-US" baseline="0" dirty="0" err="1"/>
+              <a:t>변경시</a:t>
+            </a:r>
+            <a:r>
+              <a:rPr lang="ko-KR" altLang="en-US" baseline="0" dirty="0"/>
+              <a:t> 자동으로 </a:t>
+            </a:r>
+            <a:r>
+              <a:rPr lang="en-US" altLang="ko-KR" baseline="0" dirty="0"/>
+              <a:t>HTML</a:t>
+            </a:r>
+            <a:r>
+              <a:rPr lang="ko-KR" altLang="en-US" baseline="0" dirty="0"/>
+              <a:t>에 반영되게 만들고 싶은 기능에 </a:t>
+            </a:r>
+            <a:r>
+              <a:rPr lang="en-US" altLang="ko-KR" baseline="0" dirty="0"/>
+              <a:t>state </a:t>
+            </a:r>
+            <a:r>
+              <a:rPr lang="ko-KR" altLang="en-US" baseline="0" dirty="0"/>
+              <a:t>사용</a:t>
+            </a:r>
+            <a:r>
+              <a:rPr lang="en-US" altLang="ko-KR" baseline="0" dirty="0"/>
+              <a:t>.</a:t>
+            </a:r>
           </a:p>
           <a:p>
             <a:pPr marL="171450" indent="-171450">
               <a:buFontTx/>
               <a:buChar char="-"/>
             </a:pPr>
-            <a:endParaRPr lang="en-US" altLang="ko-KR" dirty="0" smtClean="0"/>
+            <a:r>
+              <a:rPr lang="ko-KR" altLang="en-US" baseline="0" dirty="0"/>
+              <a:t>자주 변경될 것 같은 </a:t>
+            </a:r>
+            <a:r>
+              <a:rPr lang="en-US" altLang="ko-KR" baseline="0" dirty="0"/>
+              <a:t>html </a:t>
+            </a:r>
+            <a:r>
+              <a:rPr lang="ko-KR" altLang="en-US" baseline="0" dirty="0"/>
+              <a:t>요소나 내용</a:t>
+            </a:r>
+            <a:endParaRPr lang="en-US" altLang="ko-KR" baseline="0" dirty="0"/>
           </a:p>
         </p:txBody>
       </p:sp>
@@ -1010,7 +928,7 @@
           <a:p>
             <a:fld id="{C09E5BFC-1559-42F1-8940-AB342D56BF02}" type="slidenum">
               <a:rPr lang="ko-KR" altLang="en-US" smtClean="0"/>
-              <a:t>14</a:t>
+              <a:t>13</a:t>
             </a:fld>
             <a:endParaRPr lang="ko-KR" altLang="en-US"/>
           </a:p>
@@ -1019,7 +937,7 @@
     </p:spTree>
     <p:extLst>
       <p:ext uri="{BB962C8B-B14F-4D97-AF65-F5344CB8AC3E}">
-        <p14:creationId xmlns:p14="http://schemas.microsoft.com/office/powerpoint/2010/main" val="2229234871"/>
+        <p14:creationId xmlns:p14="http://schemas.microsoft.com/office/powerpoint/2010/main" val="695242521"/>
       </p:ext>
     </p:extLst>
   </p:cSld>
@@ -1073,419 +991,84 @@
           <a:bodyPr/>
           <a:lstStyle/>
           <a:p>
-            <a:pPr marL="0" marR="0" indent="0" algn="l" defTabSz="914400" rtl="0" eaLnBrk="1" fontAlgn="auto" latinLnBrk="1" hangingPunct="1">
-              <a:lnSpc>
-                <a:spcPct val="100000"/>
-              </a:lnSpc>
-              <a:spcBef>
-                <a:spcPts val="0"/>
-              </a:spcBef>
-              <a:spcAft>
-                <a:spcPts val="0"/>
-              </a:spcAft>
-              <a:buClrTx/>
-              <a:buSzTx/>
+            <a:pPr marL="171450" indent="-171450">
+              <a:buFontTx/>
+              <a:buChar char="-"/>
+            </a:pPr>
+            <a:r>
+              <a:rPr lang="en-US" altLang="ko-KR" dirty="0"/>
+              <a:t>props</a:t>
+            </a:r>
+            <a:r>
+              <a:rPr lang="ko-KR" altLang="en-US" dirty="0"/>
+              <a:t>는 자식입장에서는 수정이 불가능</a:t>
+            </a:r>
+            <a:r>
+              <a:rPr lang="en-US" altLang="ko-KR" dirty="0"/>
+              <a:t>! </a:t>
+            </a:r>
+            <a:r>
+              <a:rPr lang="ko-KR" altLang="en-US" dirty="0"/>
+              <a:t>읽기만 가능</a:t>
+            </a:r>
+            <a:r>
+              <a:rPr lang="en-US" altLang="ko-KR" dirty="0"/>
+              <a:t>!</a:t>
+            </a:r>
+          </a:p>
+          <a:p>
+            <a:pPr marL="171450" indent="-171450">
+              <a:buFontTx/>
+              <a:buChar char="-"/>
+            </a:pPr>
+            <a:r>
+              <a:rPr lang="ko-KR" altLang="en-US" dirty="0"/>
+              <a:t>변경하려면 최초 유포자 측에서 수정해야함</a:t>
+            </a:r>
+            <a:r>
+              <a:rPr lang="en-US" altLang="ko-KR" dirty="0"/>
+              <a:t>!</a:t>
+            </a:r>
+          </a:p>
+          <a:p>
+            <a:pPr marL="171450" indent="-171450">
+              <a:buFontTx/>
+              <a:buChar char="-"/>
+            </a:pPr>
+            <a:endParaRPr lang="en-US" altLang="ko-KR" dirty="0"/>
+          </a:p>
+          <a:p>
+            <a:pPr marL="0" indent="0">
               <a:buFontTx/>
               <a:buNone/>
-              <a:tabLst/>
-              <a:defRPr/>
             </a:pPr>
             <a:r>
               <a:rPr lang="en-US" altLang="ko-KR" dirty="0"/>
-              <a:t>16.3 </a:t>
-            </a:r>
+              <a:t>*</a:t>
+            </a:r>
+            <a:r>
+              <a:rPr lang="en-US" altLang="ko-KR" baseline="0" dirty="0"/>
+              <a:t> state</a:t>
+            </a:r>
+            <a:endParaRPr lang="en-US" altLang="ko-KR" dirty="0"/>
+          </a:p>
+          <a:p>
+            <a:pPr marL="171450" indent="-171450">
+              <a:buFontTx/>
+              <a:buChar char="-"/>
+            </a:pPr>
             <a:r>
               <a:rPr lang="ko-KR" altLang="en-US" dirty="0"/>
-              <a:t>버전 이전 형태</a:t>
+              <a:t>변수같은 존재</a:t>
             </a:r>
             <a:endParaRPr lang="en-US" altLang="ko-KR" dirty="0"/>
           </a:p>
           <a:p>
-            <a:pPr marL="0" marR="0" indent="0" algn="l" defTabSz="914400" rtl="0" eaLnBrk="1" fontAlgn="auto" latinLnBrk="1" hangingPunct="1">
-              <a:lnSpc>
-                <a:spcPct val="100000"/>
-              </a:lnSpc>
-              <a:spcBef>
-                <a:spcPts val="0"/>
-              </a:spcBef>
-              <a:spcAft>
-                <a:spcPts val="0"/>
-              </a:spcAft>
-              <a:buClrTx/>
-              <a:buSzTx/>
+            <a:pPr marL="171450" indent="-171450">
               <a:buFontTx/>
-              <a:buNone/>
-              <a:tabLst/>
-              <a:defRPr/>
+              <a:buChar char="-"/>
             </a:pPr>
-            <a:r>
-              <a:rPr lang="en-US" altLang="ko-KR" dirty="0"/>
-              <a:t>constructor()</a:t>
-            </a:r>
-            <a:r>
-              <a:rPr lang="en-US" altLang="ko-KR" baseline="0" dirty="0"/>
-              <a:t> : </a:t>
-            </a:r>
-            <a:r>
-              <a:rPr lang="ko-KR" altLang="en-US" baseline="0" dirty="0" err="1"/>
-              <a:t>생성자</a:t>
-            </a:r>
-            <a:r>
-              <a:rPr lang="en-US" altLang="ko-KR" baseline="0" dirty="0"/>
-              <a:t>, state </a:t>
-            </a:r>
-            <a:r>
-              <a:rPr lang="ko-KR" altLang="en-US" baseline="0" dirty="0"/>
-              <a:t>값을 초기화 하거나 메서드를 바인딩 할 때 사용</a:t>
-            </a:r>
-            <a:endParaRPr lang="en-US" altLang="ko-KR" baseline="0" dirty="0"/>
-          </a:p>
-          <a:p>
-            <a:pPr marL="0" marR="0" indent="0" algn="l" defTabSz="914400" rtl="0" eaLnBrk="1" fontAlgn="auto" latinLnBrk="1" hangingPunct="1">
-              <a:lnSpc>
-                <a:spcPct val="100000"/>
-              </a:lnSpc>
-              <a:spcBef>
-                <a:spcPts val="0"/>
-              </a:spcBef>
-              <a:spcAft>
-                <a:spcPts val="0"/>
-              </a:spcAft>
-              <a:buClrTx/>
-              <a:buSzTx/>
-              <a:buFontTx/>
-              <a:buNone/>
-              <a:tabLst/>
-              <a:defRPr/>
-            </a:pPr>
-            <a:r>
-              <a:rPr lang="ko-KR" altLang="en-US" baseline="0" dirty="0"/>
-              <a:t>해당 컴포넌트가 마운트 되기 전 호출된다 </a:t>
-            </a:r>
-            <a:r>
-              <a:rPr lang="en-US" altLang="ko-KR" baseline="0" dirty="0"/>
-              <a:t>(</a:t>
-            </a:r>
-            <a:r>
-              <a:rPr lang="ko-KR" altLang="en-US" baseline="0" dirty="0"/>
-              <a:t>마운트 </a:t>
-            </a:r>
-            <a:r>
-              <a:rPr lang="en-US" altLang="ko-KR" baseline="0" dirty="0"/>
-              <a:t>: DOM </a:t>
-            </a:r>
-            <a:r>
-              <a:rPr lang="ko-KR" altLang="en-US" baseline="0" dirty="0"/>
-              <a:t>객체가 생성되고 브라우저에 나타나는 것을 의미</a:t>
-            </a:r>
-            <a:r>
-              <a:rPr lang="en-US" altLang="ko-KR" baseline="0" dirty="0"/>
-              <a:t>)</a:t>
-            </a:r>
-          </a:p>
-          <a:p>
-            <a:pPr marL="0" marR="0" indent="0" algn="l" defTabSz="914400" rtl="0" eaLnBrk="1" fontAlgn="auto" latinLnBrk="1" hangingPunct="1">
-              <a:lnSpc>
-                <a:spcPct val="100000"/>
-              </a:lnSpc>
-              <a:spcBef>
-                <a:spcPts val="0"/>
-              </a:spcBef>
-              <a:spcAft>
-                <a:spcPts val="0"/>
-              </a:spcAft>
-              <a:buClrTx/>
-              <a:buSzTx/>
-              <a:buFontTx/>
-              <a:buNone/>
-              <a:tabLst/>
-              <a:defRPr/>
-            </a:pPr>
-            <a:r>
-              <a:rPr lang="en-US" altLang="ko-KR" baseline="0" dirty="0"/>
-              <a:t>(Mount, Update, </a:t>
-            </a:r>
-            <a:r>
-              <a:rPr lang="en-US" altLang="ko-KR" baseline="0" dirty="0" err="1"/>
-              <a:t>UnMount</a:t>
-            </a:r>
-            <a:r>
-              <a:rPr lang="en-US" altLang="ko-KR" baseline="0" dirty="0"/>
-              <a:t>) -&gt; </a:t>
-            </a:r>
-            <a:r>
-              <a:rPr lang="ko-KR" altLang="en-US" baseline="0" dirty="0"/>
-              <a:t>추후 라이프 사이클 파트에서 다룰 예정</a:t>
-            </a:r>
-            <a:endParaRPr lang="en-US" altLang="ko-KR" baseline="0" dirty="0"/>
-          </a:p>
-          <a:p>
-            <a:pPr marL="0" marR="0" indent="0" algn="l" defTabSz="914400" rtl="0" eaLnBrk="1" fontAlgn="auto" latinLnBrk="1" hangingPunct="1">
-              <a:lnSpc>
-                <a:spcPct val="100000"/>
-              </a:lnSpc>
-              <a:spcBef>
-                <a:spcPts val="0"/>
-              </a:spcBef>
-              <a:spcAft>
-                <a:spcPts val="0"/>
-              </a:spcAft>
-              <a:buClrTx/>
-              <a:buSzTx/>
-              <a:buFontTx/>
-              <a:buNone/>
-              <a:tabLst/>
-              <a:defRPr/>
-            </a:pPr>
-            <a:r>
-              <a:rPr lang="en-US" altLang="ko-KR" baseline="0" dirty="0"/>
-              <a:t>----</a:t>
-            </a:r>
-          </a:p>
-          <a:p>
-            <a:pPr marL="0" marR="0" indent="0" algn="l" defTabSz="914400" rtl="0" eaLnBrk="1" fontAlgn="auto" latinLnBrk="1" hangingPunct="1">
-              <a:lnSpc>
-                <a:spcPct val="100000"/>
-              </a:lnSpc>
-              <a:spcBef>
-                <a:spcPts val="0"/>
-              </a:spcBef>
-              <a:spcAft>
-                <a:spcPts val="0"/>
-              </a:spcAft>
-              <a:buClrTx/>
-              <a:buSzTx/>
-              <a:buFontTx/>
-              <a:buNone/>
-              <a:tabLst/>
-              <a:defRPr/>
-            </a:pPr>
-            <a:r>
-              <a:rPr lang="en-US" altLang="ko-KR" dirty="0"/>
-              <a:t>super() : </a:t>
-            </a:r>
-            <a:r>
-              <a:rPr lang="ko-KR" altLang="en-US" dirty="0"/>
-              <a:t>부모 클래스 </a:t>
-            </a:r>
-            <a:r>
-              <a:rPr lang="ko-KR" altLang="en-US" dirty="0" err="1"/>
-              <a:t>생성자</a:t>
-            </a:r>
-            <a:r>
-              <a:rPr lang="ko-KR" altLang="en-US" dirty="0"/>
-              <a:t> 가리킴</a:t>
-            </a:r>
-            <a:r>
-              <a:rPr lang="en-US" altLang="ko-KR" dirty="0"/>
-              <a:t>, super(props)</a:t>
-            </a:r>
-            <a:r>
-              <a:rPr lang="ko-KR" altLang="en-US" dirty="0"/>
-              <a:t>를 </a:t>
-            </a:r>
-            <a:r>
-              <a:rPr lang="ko-KR" altLang="en-US" dirty="0" err="1"/>
-              <a:t>선언전까지</a:t>
-            </a:r>
-            <a:r>
-              <a:rPr lang="ko-KR" altLang="en-US" dirty="0"/>
-              <a:t> </a:t>
-            </a:r>
-            <a:r>
-              <a:rPr lang="en-US" altLang="ko-KR" dirty="0"/>
-              <a:t>constructor</a:t>
-            </a:r>
-            <a:r>
-              <a:rPr lang="ko-KR" altLang="en-US" dirty="0"/>
-              <a:t>에서 </a:t>
-            </a:r>
-            <a:r>
-              <a:rPr lang="en-US" altLang="ko-KR" dirty="0"/>
-              <a:t>this</a:t>
-            </a:r>
-            <a:r>
-              <a:rPr lang="en-US" altLang="ko-KR" baseline="0" dirty="0"/>
-              <a:t> </a:t>
-            </a:r>
-            <a:r>
-              <a:rPr lang="ko-KR" altLang="en-US" baseline="0" dirty="0"/>
-              <a:t>키워드를 사용할 수 없다</a:t>
-            </a:r>
-            <a:r>
-              <a:rPr lang="en-US" altLang="ko-KR" baseline="0" dirty="0"/>
-              <a:t>(</a:t>
-            </a:r>
-            <a:r>
-              <a:rPr lang="en-US" altLang="ko-KR" baseline="0" dirty="0" err="1"/>
-              <a:t>js</a:t>
-            </a:r>
-            <a:r>
-              <a:rPr lang="ko-KR" altLang="en-US" baseline="0" dirty="0"/>
-              <a:t>에서</a:t>
-            </a:r>
-            <a:r>
-              <a:rPr lang="en-US" altLang="ko-KR" baseline="0" dirty="0"/>
-              <a:t>)</a:t>
-            </a:r>
-          </a:p>
-          <a:p>
-            <a:pPr marL="0" marR="0" indent="0" algn="l" defTabSz="914400" rtl="0" eaLnBrk="1" fontAlgn="auto" latinLnBrk="1" hangingPunct="1">
-              <a:lnSpc>
-                <a:spcPct val="100000"/>
-              </a:lnSpc>
-              <a:spcBef>
-                <a:spcPts val="0"/>
-              </a:spcBef>
-              <a:spcAft>
-                <a:spcPts val="0"/>
-              </a:spcAft>
-              <a:buClrTx/>
-              <a:buSzTx/>
-              <a:buFontTx/>
-              <a:buNone/>
-              <a:tabLst/>
-              <a:defRPr/>
-            </a:pPr>
-            <a:endParaRPr lang="en-US" altLang="ko-KR" dirty="0" smtClean="0"/>
-          </a:p>
-          <a:p>
-            <a:pPr marL="0" marR="0" indent="0" algn="l" defTabSz="914400" rtl="0" eaLnBrk="1" fontAlgn="auto" latinLnBrk="1" hangingPunct="1">
-              <a:lnSpc>
-                <a:spcPct val="100000"/>
-              </a:lnSpc>
-              <a:spcBef>
-                <a:spcPts val="0"/>
-              </a:spcBef>
-              <a:spcAft>
-                <a:spcPts val="0"/>
-              </a:spcAft>
-              <a:buClrTx/>
-              <a:buSzTx/>
-              <a:buFontTx/>
-              <a:buNone/>
-              <a:tabLst/>
-              <a:defRPr/>
-            </a:pPr>
-            <a:r>
-              <a:rPr lang="en-US" altLang="ko-KR" dirty="0" smtClean="0"/>
-              <a:t>**</a:t>
-            </a:r>
-            <a:r>
-              <a:rPr lang="en-US" altLang="ko-KR" baseline="0" dirty="0" smtClean="0"/>
-              <a:t> React 16.3 </a:t>
-            </a:r>
-            <a:r>
-              <a:rPr lang="ko-KR" altLang="en-US" baseline="0" dirty="0" smtClean="0"/>
-              <a:t>이전</a:t>
-            </a:r>
-            <a:endParaRPr lang="en-US" altLang="ko-KR" baseline="0" dirty="0" smtClean="0"/>
-          </a:p>
-          <a:p>
-            <a:pPr marL="0" marR="0" indent="0" algn="l" defTabSz="914400" rtl="0" eaLnBrk="1" fontAlgn="auto" latinLnBrk="1" hangingPunct="1">
-              <a:lnSpc>
-                <a:spcPct val="100000"/>
-              </a:lnSpc>
-              <a:spcBef>
-                <a:spcPts val="0"/>
-              </a:spcBef>
-              <a:spcAft>
-                <a:spcPts val="0"/>
-              </a:spcAft>
-              <a:buClrTx/>
-              <a:buSzTx/>
-              <a:buFontTx/>
-              <a:buNone/>
-              <a:tabLst/>
-              <a:defRPr/>
-            </a:pPr>
-            <a:r>
-              <a:rPr lang="ko-KR" altLang="en-US" baseline="0" dirty="0" smtClean="0"/>
-              <a:t>상태를 초기화하기 위해 주로</a:t>
-            </a:r>
-            <a:r>
-              <a:rPr lang="en-US" altLang="ko-KR" baseline="0" dirty="0" smtClean="0"/>
-              <a:t>‘constructor’ </a:t>
-            </a:r>
-            <a:r>
-              <a:rPr lang="ko-KR" altLang="en-US" baseline="0" dirty="0" smtClean="0"/>
-              <a:t>사용</a:t>
-            </a:r>
-            <a:r>
-              <a:rPr lang="en-US" altLang="ko-KR" baseline="0" dirty="0" smtClean="0"/>
-              <a:t>.</a:t>
-            </a:r>
-          </a:p>
-          <a:p>
-            <a:pPr marL="0" marR="0" indent="0" algn="l" defTabSz="914400" rtl="0" eaLnBrk="1" fontAlgn="auto" latinLnBrk="1" hangingPunct="1">
-              <a:lnSpc>
-                <a:spcPct val="100000"/>
-              </a:lnSpc>
-              <a:spcBef>
-                <a:spcPts val="0"/>
-              </a:spcBef>
-              <a:spcAft>
-                <a:spcPts val="0"/>
-              </a:spcAft>
-              <a:buClrTx/>
-              <a:buSzTx/>
-              <a:buFontTx/>
-              <a:buNone/>
-              <a:tabLst/>
-              <a:defRPr/>
-            </a:pPr>
-            <a:r>
-              <a:rPr lang="ko-KR" altLang="en-US" baseline="0" dirty="0" smtClean="0"/>
-              <a:t>상태 초기화는 </a:t>
-            </a:r>
-            <a:r>
-              <a:rPr lang="en-US" altLang="ko-KR" baseline="0" dirty="0" smtClean="0"/>
-              <a:t>‘</a:t>
-            </a:r>
-            <a:r>
-              <a:rPr lang="en-US" altLang="ko-KR" baseline="0" dirty="0" err="1" smtClean="0"/>
-              <a:t>this.state</a:t>
-            </a:r>
-            <a:r>
-              <a:rPr lang="en-US" altLang="ko-KR" baseline="0" dirty="0" smtClean="0"/>
-              <a:t>’</a:t>
-            </a:r>
-            <a:r>
-              <a:rPr lang="ko-KR" altLang="en-US" baseline="0" dirty="0" smtClean="0"/>
-              <a:t>에</a:t>
-            </a:r>
-            <a:r>
-              <a:rPr lang="en-US" altLang="ko-KR" baseline="0" dirty="0" smtClean="0"/>
-              <a:t> </a:t>
-            </a:r>
-            <a:r>
-              <a:rPr lang="ko-KR" altLang="en-US" baseline="0" dirty="0" smtClean="0"/>
-              <a:t>직접 할당함</a:t>
-            </a:r>
-            <a:r>
-              <a:rPr lang="en-US" altLang="ko-KR" baseline="0" dirty="0" smtClean="0"/>
-              <a:t>.</a:t>
-            </a:r>
-          </a:p>
-          <a:p>
-            <a:pPr marL="0" marR="0" indent="0" algn="l" defTabSz="914400" rtl="0" eaLnBrk="1" fontAlgn="auto" latinLnBrk="1" hangingPunct="1">
-              <a:lnSpc>
-                <a:spcPct val="100000"/>
-              </a:lnSpc>
-              <a:spcBef>
-                <a:spcPts val="0"/>
-              </a:spcBef>
-              <a:spcAft>
-                <a:spcPts val="0"/>
-              </a:spcAft>
-              <a:buClrTx/>
-              <a:buSzTx/>
-              <a:buFontTx/>
-              <a:buNone/>
-              <a:tabLst/>
-              <a:defRPr/>
-            </a:pPr>
-            <a:endParaRPr lang="ko-KR" altLang="en-US" dirty="0"/>
+            <a:endParaRPr lang="en-US" altLang="ko-KR" dirty="0"/>
           </a:p>
         </p:txBody>
       </p:sp>
@@ -1496,7 +1079,7 @@
             <a:spLocks noGrp="1"/>
           </p:cNvSpPr>
           <p:nvPr>
-            <p:ph type="sldNum" sz="quarter" idx="10"/>
+            <p:ph type="sldNum" sz="quarter" idx="5"/>
           </p:nvPr>
         </p:nvSpPr>
         <p:spPr/>
@@ -1506,7 +1089,7 @@
           <a:p>
             <a:fld id="{C09E5BFC-1559-42F1-8940-AB342D56BF02}" type="slidenum">
               <a:rPr lang="ko-KR" altLang="en-US" smtClean="0"/>
-              <a:t>15</a:t>
+              <a:t>14</a:t>
             </a:fld>
             <a:endParaRPr lang="ko-KR" altLang="en-US"/>
           </a:p>
@@ -1515,7 +1098,7 @@
     </p:spTree>
     <p:extLst>
       <p:ext uri="{BB962C8B-B14F-4D97-AF65-F5344CB8AC3E}">
-        <p14:creationId xmlns:p14="http://schemas.microsoft.com/office/powerpoint/2010/main" val="4203439928"/>
+        <p14:creationId xmlns:p14="http://schemas.microsoft.com/office/powerpoint/2010/main" val="2229234871"/>
       </p:ext>
     </p:extLst>
   </p:cSld>
@@ -1569,42 +1152,418 @@
           <a:bodyPr/>
           <a:lstStyle/>
           <a:p>
-            <a:r>
-              <a:rPr lang="ko-KR" altLang="en-US" dirty="0" smtClean="0"/>
-              <a:t>생명주기 메서드가 도입</a:t>
-            </a:r>
-            <a:r>
-              <a:rPr lang="en-US" altLang="ko-KR" dirty="0" smtClean="0"/>
-              <a:t>!</a:t>
-            </a:r>
-          </a:p>
-          <a:p>
-            <a:r>
-              <a:rPr lang="en-US" altLang="ko-KR" dirty="0" smtClean="0"/>
-              <a:t>'state'</a:t>
-            </a:r>
-            <a:r>
-              <a:rPr lang="ko-KR" altLang="en-US" dirty="0" smtClean="0"/>
-              <a:t>를 초기화 하는 방법이 생김</a:t>
-            </a:r>
-            <a:r>
-              <a:rPr lang="en-US" altLang="ko-KR" dirty="0" smtClean="0"/>
+            <a:pPr marL="0" marR="0" indent="0" algn="l" defTabSz="914400" rtl="0" eaLnBrk="1" fontAlgn="auto" latinLnBrk="1" hangingPunct="1">
+              <a:lnSpc>
+                <a:spcPct val="100000"/>
+              </a:lnSpc>
+              <a:spcBef>
+                <a:spcPts val="0"/>
+              </a:spcBef>
+              <a:spcAft>
+                <a:spcPts val="0"/>
+              </a:spcAft>
+              <a:buClrTx/>
+              <a:buSzTx/>
+              <a:buFontTx/>
+              <a:buNone/>
+              <a:tabLst/>
+              <a:defRPr/>
+            </a:pPr>
+            <a:r>
+              <a:rPr lang="en-US" altLang="ko-KR" dirty="0"/>
+              <a:t>16.3 </a:t>
+            </a:r>
+            <a:r>
+              <a:rPr lang="ko-KR" altLang="en-US" dirty="0"/>
+              <a:t>버전 이전 형태</a:t>
+            </a:r>
+            <a:endParaRPr lang="en-US" altLang="ko-KR" dirty="0"/>
+          </a:p>
+          <a:p>
+            <a:pPr marL="0" marR="0" indent="0" algn="l" defTabSz="914400" rtl="0" eaLnBrk="1" fontAlgn="auto" latinLnBrk="1" hangingPunct="1">
+              <a:lnSpc>
+                <a:spcPct val="100000"/>
+              </a:lnSpc>
+              <a:spcBef>
+                <a:spcPts val="0"/>
+              </a:spcBef>
+              <a:spcAft>
+                <a:spcPts val="0"/>
+              </a:spcAft>
+              <a:buClrTx/>
+              <a:buSzTx/>
+              <a:buFontTx/>
+              <a:buNone/>
+              <a:tabLst/>
+              <a:defRPr/>
+            </a:pPr>
+            <a:r>
+              <a:rPr lang="en-US" altLang="ko-KR" dirty="0"/>
+              <a:t>constructor()</a:t>
+            </a:r>
+            <a:r>
+              <a:rPr lang="en-US" altLang="ko-KR" baseline="0" dirty="0"/>
+              <a:t> : </a:t>
+            </a:r>
+            <a:r>
+              <a:rPr lang="ko-KR" altLang="en-US" baseline="0" dirty="0" err="1"/>
+              <a:t>생성자</a:t>
+            </a:r>
+            <a:r>
+              <a:rPr lang="en-US" altLang="ko-KR" baseline="0" dirty="0"/>
+              <a:t>, state </a:t>
+            </a:r>
+            <a:r>
+              <a:rPr lang="ko-KR" altLang="en-US" baseline="0" dirty="0"/>
+              <a:t>값을 초기화 하거나 메서드를 바인딩 할 때 사용</a:t>
+            </a:r>
+            <a:endParaRPr lang="en-US" altLang="ko-KR" baseline="0" dirty="0"/>
+          </a:p>
+          <a:p>
+            <a:pPr marL="0" marR="0" indent="0" algn="l" defTabSz="914400" rtl="0" eaLnBrk="1" fontAlgn="auto" latinLnBrk="1" hangingPunct="1">
+              <a:lnSpc>
+                <a:spcPct val="100000"/>
+              </a:lnSpc>
+              <a:spcBef>
+                <a:spcPts val="0"/>
+              </a:spcBef>
+              <a:spcAft>
+                <a:spcPts val="0"/>
+              </a:spcAft>
+              <a:buClrTx/>
+              <a:buSzTx/>
+              <a:buFontTx/>
+              <a:buNone/>
+              <a:tabLst/>
+              <a:defRPr/>
+            </a:pPr>
+            <a:r>
+              <a:rPr lang="ko-KR" altLang="en-US" baseline="0" dirty="0"/>
+              <a:t>해당 컴포넌트가 마운트 되기 전 호출된다 </a:t>
+            </a:r>
+            <a:r>
+              <a:rPr lang="en-US" altLang="ko-KR" baseline="0" dirty="0"/>
+              <a:t>(</a:t>
+            </a:r>
+            <a:r>
+              <a:rPr lang="ko-KR" altLang="en-US" baseline="0" dirty="0"/>
+              <a:t>마운트 </a:t>
+            </a:r>
+            <a:r>
+              <a:rPr lang="en-US" altLang="ko-KR" baseline="0" dirty="0"/>
+              <a:t>: DOM </a:t>
+            </a:r>
+            <a:r>
+              <a:rPr lang="ko-KR" altLang="en-US" baseline="0" dirty="0"/>
+              <a:t>객체가 생성되고 브라우저에 나타나는 것을 의미</a:t>
+            </a:r>
+            <a:r>
+              <a:rPr lang="en-US" altLang="ko-KR" baseline="0" dirty="0"/>
+              <a:t>)</a:t>
+            </a:r>
+          </a:p>
+          <a:p>
+            <a:pPr marL="0" marR="0" indent="0" algn="l" defTabSz="914400" rtl="0" eaLnBrk="1" fontAlgn="auto" latinLnBrk="1" hangingPunct="1">
+              <a:lnSpc>
+                <a:spcPct val="100000"/>
+              </a:lnSpc>
+              <a:spcBef>
+                <a:spcPts val="0"/>
+              </a:spcBef>
+              <a:spcAft>
+                <a:spcPts val="0"/>
+              </a:spcAft>
+              <a:buClrTx/>
+              <a:buSzTx/>
+              <a:buFontTx/>
+              <a:buNone/>
+              <a:tabLst/>
+              <a:defRPr/>
+            </a:pPr>
+            <a:r>
+              <a:rPr lang="en-US" altLang="ko-KR" baseline="0" dirty="0"/>
+              <a:t>(Mount, Update, </a:t>
+            </a:r>
+            <a:r>
+              <a:rPr lang="en-US" altLang="ko-KR" baseline="0" dirty="0" err="1"/>
+              <a:t>UnMount</a:t>
+            </a:r>
+            <a:r>
+              <a:rPr lang="en-US" altLang="ko-KR" baseline="0" dirty="0"/>
+              <a:t>) -&gt; </a:t>
+            </a:r>
+            <a:r>
+              <a:rPr lang="ko-KR" altLang="en-US" baseline="0" dirty="0"/>
+              <a:t>추후 라이프 사이클 파트에서 다룰 예정</a:t>
+            </a:r>
+            <a:endParaRPr lang="en-US" altLang="ko-KR" baseline="0" dirty="0"/>
+          </a:p>
+          <a:p>
+            <a:pPr marL="0" marR="0" indent="0" algn="l" defTabSz="914400" rtl="0" eaLnBrk="1" fontAlgn="auto" latinLnBrk="1" hangingPunct="1">
+              <a:lnSpc>
+                <a:spcPct val="100000"/>
+              </a:lnSpc>
+              <a:spcBef>
+                <a:spcPts val="0"/>
+              </a:spcBef>
+              <a:spcAft>
+                <a:spcPts val="0"/>
+              </a:spcAft>
+              <a:buClrTx/>
+              <a:buSzTx/>
+              <a:buFontTx/>
+              <a:buNone/>
+              <a:tabLst/>
+              <a:defRPr/>
+            </a:pPr>
+            <a:r>
+              <a:rPr lang="en-US" altLang="ko-KR" baseline="0" dirty="0"/>
+              <a:t>----</a:t>
+            </a:r>
+          </a:p>
+          <a:p>
+            <a:pPr marL="0" marR="0" indent="0" algn="l" defTabSz="914400" rtl="0" eaLnBrk="1" fontAlgn="auto" latinLnBrk="1" hangingPunct="1">
+              <a:lnSpc>
+                <a:spcPct val="100000"/>
+              </a:lnSpc>
+              <a:spcBef>
+                <a:spcPts val="0"/>
+              </a:spcBef>
+              <a:spcAft>
+                <a:spcPts val="0"/>
+              </a:spcAft>
+              <a:buClrTx/>
+              <a:buSzTx/>
+              <a:buFontTx/>
+              <a:buNone/>
+              <a:tabLst/>
+              <a:defRPr/>
+            </a:pPr>
+            <a:r>
+              <a:rPr lang="en-US" altLang="ko-KR" dirty="0"/>
+              <a:t>super() : </a:t>
+            </a:r>
+            <a:r>
+              <a:rPr lang="ko-KR" altLang="en-US" dirty="0"/>
+              <a:t>부모 클래스 </a:t>
+            </a:r>
+            <a:r>
+              <a:rPr lang="ko-KR" altLang="en-US" dirty="0" err="1"/>
+              <a:t>생성자</a:t>
+            </a:r>
+            <a:r>
+              <a:rPr lang="ko-KR" altLang="en-US" dirty="0"/>
+              <a:t> 가리킴</a:t>
+            </a:r>
+            <a:r>
+              <a:rPr lang="en-US" altLang="ko-KR" dirty="0"/>
+              <a:t>, super(props)</a:t>
+            </a:r>
+            <a:r>
+              <a:rPr lang="ko-KR" altLang="en-US" dirty="0"/>
+              <a:t>를 </a:t>
+            </a:r>
+            <a:r>
+              <a:rPr lang="ko-KR" altLang="en-US" dirty="0" err="1"/>
+              <a:t>선언전까지</a:t>
+            </a:r>
+            <a:r>
+              <a:rPr lang="ko-KR" altLang="en-US" dirty="0"/>
+              <a:t> </a:t>
+            </a:r>
+            <a:r>
+              <a:rPr lang="en-US" altLang="ko-KR" dirty="0"/>
+              <a:t>constructor</a:t>
+            </a:r>
+            <a:r>
+              <a:rPr lang="ko-KR" altLang="en-US" dirty="0"/>
+              <a:t>에서 </a:t>
+            </a:r>
+            <a:r>
+              <a:rPr lang="en-US" altLang="ko-KR" dirty="0"/>
+              <a:t>this</a:t>
+            </a:r>
+            <a:r>
+              <a:rPr lang="en-US" altLang="ko-KR" baseline="0" dirty="0"/>
+              <a:t> </a:t>
+            </a:r>
+            <a:r>
+              <a:rPr lang="ko-KR" altLang="en-US" baseline="0" dirty="0"/>
+              <a:t>키워드를 사용할 수 없다</a:t>
+            </a:r>
+            <a:r>
+              <a:rPr lang="en-US" altLang="ko-KR" baseline="0" dirty="0"/>
+              <a:t>(</a:t>
+            </a:r>
+            <a:r>
+              <a:rPr lang="en-US" altLang="ko-KR" baseline="0" dirty="0" err="1"/>
+              <a:t>js</a:t>
+            </a:r>
+            <a:r>
+              <a:rPr lang="ko-KR" altLang="en-US" baseline="0" dirty="0"/>
+              <a:t>에서</a:t>
+            </a:r>
+            <a:r>
+              <a:rPr lang="en-US" altLang="ko-KR" baseline="0" dirty="0"/>
+              <a:t>)</a:t>
+            </a:r>
+          </a:p>
+          <a:p>
+            <a:pPr marL="0" marR="0" indent="0" algn="l" defTabSz="914400" rtl="0" eaLnBrk="1" fontAlgn="auto" latinLnBrk="1" hangingPunct="1">
+              <a:lnSpc>
+                <a:spcPct val="100000"/>
+              </a:lnSpc>
+              <a:spcBef>
+                <a:spcPts val="0"/>
+              </a:spcBef>
+              <a:spcAft>
+                <a:spcPts val="0"/>
+              </a:spcAft>
+              <a:buClrTx/>
+              <a:buSzTx/>
+              <a:buFontTx/>
+              <a:buNone/>
+              <a:tabLst/>
+              <a:defRPr/>
+            </a:pPr>
+            <a:endParaRPr lang="en-US" altLang="ko-KR" dirty="0"/>
+          </a:p>
+          <a:p>
+            <a:pPr marL="0" marR="0" indent="0" algn="l" defTabSz="914400" rtl="0" eaLnBrk="1" fontAlgn="auto" latinLnBrk="1" hangingPunct="1">
+              <a:lnSpc>
+                <a:spcPct val="100000"/>
+              </a:lnSpc>
+              <a:spcBef>
+                <a:spcPts val="0"/>
+              </a:spcBef>
+              <a:spcAft>
+                <a:spcPts val="0"/>
+              </a:spcAft>
+              <a:buClrTx/>
+              <a:buSzTx/>
+              <a:buFontTx/>
+              <a:buNone/>
+              <a:tabLst/>
+              <a:defRPr/>
+            </a:pPr>
+            <a:r>
+              <a:rPr lang="en-US" altLang="ko-KR" dirty="0"/>
+              <a:t>**</a:t>
+            </a:r>
+            <a:r>
+              <a:rPr lang="en-US" altLang="ko-KR" baseline="0" dirty="0"/>
+              <a:t> React 16.3 </a:t>
+            </a:r>
+            <a:r>
+              <a:rPr lang="ko-KR" altLang="en-US" baseline="0" dirty="0"/>
+              <a:t>이전</a:t>
+            </a:r>
+            <a:endParaRPr lang="en-US" altLang="ko-KR" baseline="0" dirty="0"/>
+          </a:p>
+          <a:p>
+            <a:pPr marL="0" marR="0" indent="0" algn="l" defTabSz="914400" rtl="0" eaLnBrk="1" fontAlgn="auto" latinLnBrk="1" hangingPunct="1">
+              <a:lnSpc>
+                <a:spcPct val="100000"/>
+              </a:lnSpc>
+              <a:spcBef>
+                <a:spcPts val="0"/>
+              </a:spcBef>
+              <a:spcAft>
+                <a:spcPts val="0"/>
+              </a:spcAft>
+              <a:buClrTx/>
+              <a:buSzTx/>
+              <a:buFontTx/>
+              <a:buNone/>
+              <a:tabLst/>
+              <a:defRPr/>
+            </a:pPr>
+            <a:r>
+              <a:rPr lang="ko-KR" altLang="en-US" baseline="0" dirty="0"/>
+              <a:t>상태를 초기화하기 위해 주로</a:t>
+            </a:r>
+            <a:r>
+              <a:rPr lang="en-US" altLang="ko-KR" baseline="0" dirty="0"/>
+              <a:t>‘constructor’ </a:t>
+            </a:r>
+            <a:r>
+              <a:rPr lang="ko-KR" altLang="en-US" baseline="0" dirty="0"/>
+              <a:t>사용</a:t>
+            </a:r>
+            <a:r>
+              <a:rPr lang="en-US" altLang="ko-KR" baseline="0" dirty="0"/>
               <a:t>.</a:t>
             </a:r>
           </a:p>
           <a:p>
-            <a:r>
-              <a:rPr lang="en-US" altLang="ko-KR" dirty="0" smtClean="0"/>
-              <a:t>Constructor</a:t>
-            </a:r>
-            <a:r>
-              <a:rPr lang="ko-KR" altLang="en-US" dirty="0" smtClean="0"/>
-              <a:t>가 필요 없어짐</a:t>
-            </a:r>
-            <a:r>
-              <a:rPr lang="en-US" altLang="ko-KR" dirty="0" smtClean="0"/>
+            <a:pPr marL="0" marR="0" indent="0" algn="l" defTabSz="914400" rtl="0" eaLnBrk="1" fontAlgn="auto" latinLnBrk="1" hangingPunct="1">
+              <a:lnSpc>
+                <a:spcPct val="100000"/>
+              </a:lnSpc>
+              <a:spcBef>
+                <a:spcPts val="0"/>
+              </a:spcBef>
+              <a:spcAft>
+                <a:spcPts val="0"/>
+              </a:spcAft>
+              <a:buClrTx/>
+              <a:buSzTx/>
+              <a:buFontTx/>
+              <a:buNone/>
+              <a:tabLst/>
+              <a:defRPr/>
+            </a:pPr>
+            <a:r>
+              <a:rPr lang="ko-KR" altLang="en-US" baseline="0" dirty="0"/>
+              <a:t>상태 초기화는 </a:t>
+            </a:r>
+            <a:r>
+              <a:rPr lang="en-US" altLang="ko-KR" baseline="0" dirty="0"/>
+              <a:t>‘</a:t>
+            </a:r>
+            <a:r>
+              <a:rPr lang="en-US" altLang="ko-KR" baseline="0" dirty="0" err="1"/>
+              <a:t>this.state</a:t>
+            </a:r>
+            <a:r>
+              <a:rPr lang="en-US" altLang="ko-KR" baseline="0" dirty="0"/>
+              <a:t>’</a:t>
+            </a:r>
+            <a:r>
+              <a:rPr lang="ko-KR" altLang="en-US" baseline="0" dirty="0"/>
+              <a:t>에</a:t>
+            </a:r>
+            <a:r>
+              <a:rPr lang="en-US" altLang="ko-KR" baseline="0" dirty="0"/>
+              <a:t> </a:t>
+            </a:r>
+            <a:r>
+              <a:rPr lang="ko-KR" altLang="en-US" baseline="0" dirty="0"/>
+              <a:t>직접 할당함</a:t>
+            </a:r>
+            <a:r>
+              <a:rPr lang="en-US" altLang="ko-KR" baseline="0" dirty="0"/>
               <a:t>.</a:t>
             </a:r>
+          </a:p>
+          <a:p>
+            <a:pPr marL="0" marR="0" indent="0" algn="l" defTabSz="914400" rtl="0" eaLnBrk="1" fontAlgn="auto" latinLnBrk="1" hangingPunct="1">
+              <a:lnSpc>
+                <a:spcPct val="100000"/>
+              </a:lnSpc>
+              <a:spcBef>
+                <a:spcPts val="0"/>
+              </a:spcBef>
+              <a:spcAft>
+                <a:spcPts val="0"/>
+              </a:spcAft>
+              <a:buClrTx/>
+              <a:buSzTx/>
+              <a:buFontTx/>
+              <a:buNone/>
+              <a:tabLst/>
+              <a:defRPr/>
+            </a:pPr>
             <a:endParaRPr lang="ko-KR" altLang="en-US" dirty="0"/>
           </a:p>
         </p:txBody>
@@ -1626,7 +1585,7 @@
           <a:p>
             <a:fld id="{C09E5BFC-1559-42F1-8940-AB342D56BF02}" type="slidenum">
               <a:rPr lang="ko-KR" altLang="en-US" smtClean="0"/>
-              <a:t>16</a:t>
+              <a:t>15</a:t>
             </a:fld>
             <a:endParaRPr lang="ko-KR" altLang="en-US"/>
           </a:p>
@@ -1635,7 +1594,7 @@
     </p:spTree>
     <p:extLst>
       <p:ext uri="{BB962C8B-B14F-4D97-AF65-F5344CB8AC3E}">
-        <p14:creationId xmlns:p14="http://schemas.microsoft.com/office/powerpoint/2010/main" val="2729950675"/>
+        <p14:creationId xmlns:p14="http://schemas.microsoft.com/office/powerpoint/2010/main" val="4203439928"/>
       </p:ext>
     </p:extLst>
   </p:cSld>
@@ -1689,6 +1648,42 @@
           <a:bodyPr/>
           <a:lstStyle/>
           <a:p>
+            <a:r>
+              <a:rPr lang="ko-KR" altLang="en-US" dirty="0"/>
+              <a:t>생명주기 메서드가 도입</a:t>
+            </a:r>
+            <a:r>
+              <a:rPr lang="en-US" altLang="ko-KR" dirty="0"/>
+              <a:t>!</a:t>
+            </a:r>
+          </a:p>
+          <a:p>
+            <a:r>
+              <a:rPr lang="en-US" altLang="ko-KR" dirty="0"/>
+              <a:t>'state'</a:t>
+            </a:r>
+            <a:r>
+              <a:rPr lang="ko-KR" altLang="en-US" dirty="0"/>
+              <a:t>를 초기화 하는 방법이 생김</a:t>
+            </a:r>
+            <a:r>
+              <a:rPr lang="en-US" altLang="ko-KR" dirty="0"/>
+              <a:t>.</a:t>
+            </a:r>
+          </a:p>
+          <a:p>
+            <a:r>
+              <a:rPr lang="en-US" altLang="ko-KR" dirty="0"/>
+              <a:t>Constructor</a:t>
+            </a:r>
+            <a:r>
+              <a:rPr lang="ko-KR" altLang="en-US" dirty="0"/>
+              <a:t>가 필요 없어짐</a:t>
+            </a:r>
+            <a:r>
+              <a:rPr lang="en-US" altLang="ko-KR" dirty="0"/>
+              <a:t>.</a:t>
+            </a:r>
             <a:endParaRPr lang="ko-KR" altLang="en-US" dirty="0"/>
           </a:p>
         </p:txBody>
@@ -1710,7 +1705,7 @@
           <a:p>
             <a:fld id="{C09E5BFC-1559-42F1-8940-AB342D56BF02}" type="slidenum">
               <a:rPr lang="ko-KR" altLang="en-US" smtClean="0"/>
-              <a:t>17</a:t>
+              <a:t>16</a:t>
             </a:fld>
             <a:endParaRPr lang="ko-KR" altLang="en-US"/>
           </a:p>
@@ -1719,7 +1714,7 @@
     </p:spTree>
     <p:extLst>
       <p:ext uri="{BB962C8B-B14F-4D97-AF65-F5344CB8AC3E}">
-        <p14:creationId xmlns:p14="http://schemas.microsoft.com/office/powerpoint/2010/main" val="3906120493"/>
+        <p14:creationId xmlns:p14="http://schemas.microsoft.com/office/powerpoint/2010/main" val="2729950675"/>
       </p:ext>
     </p:extLst>
   </p:cSld>
@@ -1784,6 +1779,90 @@
             <a:spLocks noGrp="1"/>
           </p:cNvSpPr>
           <p:nvPr>
+            <p:ph type="sldNum" sz="quarter" idx="10"/>
+          </p:nvPr>
+        </p:nvSpPr>
+        <p:spPr/>
+        <p:txBody>
+          <a:bodyPr/>
+          <a:lstStyle/>
+          <a:p>
+            <a:fld id="{C09E5BFC-1559-42F1-8940-AB342D56BF02}" type="slidenum">
+              <a:rPr lang="ko-KR" altLang="en-US" smtClean="0"/>
+              <a:t>17</a:t>
+            </a:fld>
+            <a:endParaRPr lang="ko-KR" altLang="en-US"/>
+          </a:p>
+        </p:txBody>
+      </p:sp>
+    </p:spTree>
+    <p:extLst>
+      <p:ext uri="{BB962C8B-B14F-4D97-AF65-F5344CB8AC3E}">
+        <p14:creationId xmlns:p14="http://schemas.microsoft.com/office/powerpoint/2010/main" val="3906120493"/>
+      </p:ext>
+    </p:extLst>
+  </p:cSld>
+  <p:clrMapOvr>
+    <a:masterClrMapping/>
+  </p:clrMapOvr>
+</p:notes>
+</file>
+
+<file path=ppt/notesSlides/notesSlide16.xml><?xml version="1.0" encoding="utf-8"?>
+<p:notes xmlns:a="http://schemas.openxmlformats.org/drawingml/2006/main" xmlns:r="http://schemas.openxmlformats.org/officeDocument/2006/relationships" xmlns:p="http://schemas.openxmlformats.org/presentationml/2006/main">
+  <p:cSld>
+    <p:spTree>
+      <p:nvGrpSpPr>
+        <p:cNvPr id="1" name=""/>
+        <p:cNvGrpSpPr/>
+        <p:nvPr/>
+      </p:nvGrpSpPr>
+      <p:grpSpPr>
+        <a:xfrm>
+          <a:off x="0" y="0"/>
+          <a:ext cx="0" cy="0"/>
+          <a:chOff x="0" y="0"/>
+          <a:chExt cx="0" cy="0"/>
+        </a:xfrm>
+      </p:grpSpPr>
+      <p:sp>
+        <p:nvSpPr>
+          <p:cNvPr id="2" name="슬라이드 이미지 개체 틀 1"/>
+          <p:cNvSpPr>
+            <a:spLocks noGrp="1" noRot="1" noChangeAspect="1"/>
+          </p:cNvSpPr>
+          <p:nvPr>
+            <p:ph type="sldImg"/>
+          </p:nvPr>
+        </p:nvSpPr>
+        <p:spPr/>
+      </p:sp>
+      <p:sp>
+        <p:nvSpPr>
+          <p:cNvPr id="3" name="슬라이드 노트 개체 틀 2"/>
+          <p:cNvSpPr>
+            <a:spLocks noGrp="1"/>
+          </p:cNvSpPr>
+          <p:nvPr>
+            <p:ph type="body" idx="1"/>
+          </p:nvPr>
+        </p:nvSpPr>
+        <p:spPr/>
+        <p:txBody>
+          <a:bodyPr/>
+          <a:lstStyle/>
+          <a:p>
+            <a:endParaRPr lang="ko-KR" altLang="en-US" dirty="0"/>
+          </a:p>
+        </p:txBody>
+      </p:sp>
+      <p:sp>
+        <p:nvSpPr>
+          <p:cNvPr id="4" name="슬라이드 번호 개체 틀 3"/>
+          <p:cNvSpPr>
+            <a:spLocks noGrp="1"/>
+          </p:cNvSpPr>
+          <p:nvPr>
             <p:ph type="sldNum" sz="quarter" idx="5"/>
           </p:nvPr>
         </p:nvSpPr>
@@ -1813,7 +1892,7 @@
 </p:notes>
 </file>
 
-<file path=ppt/notesSlides/notesSlide16.xml><?xml version="1.0" encoding="utf-8"?>
+<file path=ppt/notesSlides/notesSlide17.xml><?xml version="1.0" encoding="utf-8"?>
 <p:notes xmlns:a="http://schemas.openxmlformats.org/drawingml/2006/main" xmlns:r="http://schemas.openxmlformats.org/officeDocument/2006/relationships" xmlns:p="http://schemas.openxmlformats.org/presentationml/2006/main">
   <p:cSld>
     <p:spTree>
@@ -6652,7 +6731,7 @@
           <a:p>
             <a:fld id="{0F78D9C4-20C1-4B15-A116-16DC77AD9A1E}" type="datetime1">
               <a:rPr lang="ko-KR" altLang="en-US" smtClean="0"/>
-              <a:t>2024-08-04</a:t>
+              <a:t>2024-08-05</a:t>
             </a:fld>
             <a:endParaRPr lang="ko-KR" altLang="en-US"/>
           </a:p>
@@ -6995,15 +7074,6 @@
                 <a:latin typeface="+mn-ea"/>
               </a:rPr>
               <a:t>강의 클릭</a:t>
-            </a:r>
-            <a:r>
-              <a:rPr lang="en-US" altLang="ko-KR" dirty="0">
-                <a:solidFill>
-                  <a:srgbClr val="212529"/>
-                </a:solidFill>
-                <a:latin typeface="+mn-ea"/>
-              </a:rPr>
-              <a:t/>
             </a:r>
             <a:br>
               <a:rPr lang="en-US" altLang="ko-KR" dirty="0">
@@ -7245,7 +7315,7 @@
           <a:p>
             <a:fld id="{0F78D9C4-20C1-4B15-A116-16DC77AD9A1E}" type="datetime1">
               <a:rPr lang="ko-KR" altLang="en-US" smtClean="0"/>
-              <a:t>2024-08-04</a:t>
+              <a:t>2024-08-05</a:t>
             </a:fld>
             <a:endParaRPr lang="ko-KR" altLang="en-US"/>
           </a:p>
@@ -7588,15 +7658,6 @@
                 <a:latin typeface="+mn-ea"/>
               </a:rPr>
               <a:t>강의 클릭</a:t>
-            </a:r>
-            <a:r>
-              <a:rPr lang="en-US" altLang="ko-KR" dirty="0">
-                <a:solidFill>
-                  <a:srgbClr val="212529"/>
-                </a:solidFill>
-                <a:latin typeface="+mn-ea"/>
-              </a:rPr>
-              <a:t/>
             </a:r>
             <a:br>
               <a:rPr lang="en-US" altLang="ko-KR" dirty="0">
@@ -9898,7 +9959,7 @@
         </p:nvSpPr>
         <p:spPr>
           <a:xfrm>
-            <a:off x="9499407" y="1576837"/>
+            <a:off x="9158625" y="1565212"/>
             <a:ext cx="1710061" cy="426800"/>
           </a:xfrm>
           <a:prstGeom prst="rect">
@@ -10010,7 +10071,7 @@
         </p:nvSpPr>
         <p:spPr>
           <a:xfrm>
-            <a:off x="7839185" y="3621489"/>
+            <a:off x="7541819" y="3039326"/>
             <a:ext cx="1154208" cy="352063"/>
           </a:xfrm>
           <a:prstGeom prst="rect">
@@ -10122,7 +10183,7 @@
         </p:nvSpPr>
         <p:spPr>
           <a:xfrm>
-            <a:off x="7839185" y="3973552"/>
+            <a:off x="7549010" y="3365369"/>
             <a:ext cx="3219229" cy="360978"/>
           </a:xfrm>
           <a:prstGeom prst="rect">
@@ -10464,16 +10525,6 @@
                 </a:solidFill>
               </a:rPr>
               <a:t> ]</a:t>
-            </a:r>
-            <a:r>
-              <a:rPr lang="en-US" altLang="ko-KR" sz="2000" dirty="0">
-                <a:solidFill>
-                  <a:schemeClr val="bg1">
-                    <a:lumMod val="50000"/>
-                  </a:schemeClr>
-                </a:solidFill>
-              </a:rPr>
-              <a:t/>
             </a:r>
             <a:br>
               <a:rPr lang="en-US" altLang="ko-KR" sz="2000" dirty="0">
@@ -10865,7 +10916,7 @@
           <a:p>
             <a:fld id="{0F78D9C4-20C1-4B15-A116-16DC77AD9A1E}" type="datetime1">
               <a:rPr lang="ko-KR" altLang="en-US" smtClean="0"/>
-              <a:t>2024-08-04</a:t>
+              <a:t>2024-08-05</a:t>
             </a:fld>
             <a:endParaRPr lang="ko-KR" altLang="en-US"/>
           </a:p>
@@ -11208,15 +11259,6 @@
                 <a:latin typeface="+mn-ea"/>
               </a:rPr>
               <a:t>강의 클릭</a:t>
-            </a:r>
-            <a:r>
-              <a:rPr lang="en-US" altLang="ko-KR" dirty="0">
-                <a:solidFill>
-                  <a:srgbClr val="212529"/>
-                </a:solidFill>
-                <a:latin typeface="+mn-ea"/>
-              </a:rPr>
-              <a:t/>
             </a:r>
             <a:br>
               <a:rPr lang="en-US" altLang="ko-KR" dirty="0">

</xml_diff>